<commit_message>
feat(sesi-08): finalize production release apk, keystore signing, and 50 uas exam engine to pedagogical gold standard
</commit_message>
<xml_diff>
--- a/slide_presentasi/SESI_08_Optimasi_Build_APK_dan_Bank_Soal_UAS.pptx
+++ b/slide_presentasi/SESI_08_Optimasi_Build_APK_dan_Bank_Soal_UAS.pptx
@@ -3156,8 +3156,8 @@
         </p:nvSpPr>
         <p:spPr>
           <a:xfrm>
-            <a:off x="896112" y="896112"/>
-            <a:ext cx="10545775" cy="5212080"/>
+            <a:off x="896112" y="530352"/>
+            <a:ext cx="10545775" cy="5897880"/>
           </a:xfrm>
           <a:prstGeom prst="rect">
             <a:avLst/>
@@ -3199,8 +3199,8 @@
         </p:nvSpPr>
         <p:spPr>
           <a:xfrm>
-            <a:off x="822960" y="822960"/>
-            <a:ext cx="10545775" cy="5212080"/>
+            <a:off x="822960" y="457200"/>
+            <a:ext cx="10545775" cy="5897880"/>
           </a:xfrm>
           <a:prstGeom prst="rect">
             <a:avLst/>
@@ -3244,8 +3244,8 @@
         </p:nvSpPr>
         <p:spPr>
           <a:xfrm>
-            <a:off x="1280160" y="1188720"/>
-            <a:ext cx="9601200" cy="4389120"/>
+            <a:off x="1097280" y="594360"/>
+            <a:ext cx="9997135" cy="1371600"/>
           </a:xfrm>
           <a:prstGeom prst="rect">
             <a:avLst/>
@@ -3260,9 +3260,9 @@
           <a:p>
             <a:pPr>
               <a:spcAft>
-                <a:spcPts val="1600"/>
+                <a:spcPts val="400"/>
               </a:spcAft>
-              <a:defRPr sz="1200" b="1">
+              <a:defRPr sz="1100" b="1">
                 <a:solidFill>
                   <a:srgbClr val="000000"/>
                 </a:solidFill>
@@ -3270,15 +3270,15 @@
               </a:defRPr>
             </a:pPr>
             <a:r>
-              <a:t>✦ STSI4303 • PEMROGRAMAN BERBASIS PERANGKAT BERGERAK • SESI 08 (SESI PENUTUP) ✦</a:t>
+              <a:t>✦ STSI4303 • PEMROGRAMAN BERBASIS PERANGKAT BERGERAK • SESI 08 (GRAND FINALE &amp; PENUTUP SEMESTER) ✦</a:t>
             </a:r>
           </a:p>
           <a:p>
             <a:pPr>
               <a:spcAft>
-                <a:spcPts val="1400"/>
+                <a:spcPts val="400"/>
               </a:spcAft>
-              <a:defRPr sz="2600" b="1">
+              <a:defRPr sz="2100" b="1">
                 <a:solidFill>
                   <a:srgbClr val="000000"/>
                 </a:solidFill>
@@ -3291,23 +3291,567 @@
           </a:p>
           <a:p>
             <a:pPr>
+              <a:defRPr sz="1050">
+                <a:solidFill>
+                  <a:srgbClr val="464646"/>
+                </a:solidFill>
+                <a:latin typeface="Segoe UI"/>
+              </a:defRPr>
+            </a:pPr>
+            <a:r>
+              <a:t>Dari Kode Web Hybrid Menjadi Berkas Biner Android Mandiri yang Siap Edar serta Pembedahan Tuntas 50 Soal Komprehensif Ujian Akhir Semester</a:t>
+            </a:r>
+          </a:p>
+        </p:txBody>
+      </p:sp>
+      <p:sp>
+        <p:nvSpPr>
+          <p:cNvPr id="6" name="Rectangle 5"/>
+          <p:cNvSpPr/>
+          <p:nvPr/>
+        </p:nvSpPr>
+        <p:spPr>
+          <a:xfrm>
+            <a:off x="1170432" y="2130552"/>
+            <a:ext cx="4864608" cy="2468880"/>
+          </a:xfrm>
+          <a:prstGeom prst="rect">
+            <a:avLst/>
+          </a:prstGeom>
+          <a:solidFill>
+            <a:srgbClr val="000000"/>
+          </a:solidFill>
+          <a:ln>
+            <a:noFill/>
+          </a:ln>
+        </p:spPr>
+        <p:style>
+          <a:lnRef idx="1">
+            <a:schemeClr val="accent1"/>
+          </a:lnRef>
+          <a:fillRef idx="3">
+            <a:schemeClr val="accent1"/>
+          </a:fillRef>
+          <a:effectRef idx="2">
+            <a:schemeClr val="accent1"/>
+          </a:effectRef>
+          <a:fontRef idx="minor">
+            <a:schemeClr val="lt1"/>
+          </a:fontRef>
+        </p:style>
+        <p:txBody>
+          <a:bodyPr rtlCol="0" anchor="ctr"/>
+          <a:lstStyle/>
+          <a:p>
+            <a:pPr algn="ctr"/>
+          </a:p>
+        </p:txBody>
+      </p:sp>
+      <p:sp>
+        <p:nvSpPr>
+          <p:cNvPr id="7" name="Rectangle 6"/>
+          <p:cNvSpPr/>
+          <p:nvPr/>
+        </p:nvSpPr>
+        <p:spPr>
+          <a:xfrm>
+            <a:off x="1097280" y="2057400"/>
+            <a:ext cx="4864608" cy="2468880"/>
+          </a:xfrm>
+          <a:prstGeom prst="rect">
+            <a:avLst/>
+          </a:prstGeom>
+          <a:solidFill>
+            <a:srgbClr val="F5F3FF"/>
+          </a:solidFill>
+          <a:ln w="31750">
+            <a:solidFill>
+              <a:srgbClr val="000000"/>
+            </a:solidFill>
+          </a:ln>
+        </p:spPr>
+        <p:style>
+          <a:lnRef idx="1">
+            <a:schemeClr val="accent1"/>
+          </a:lnRef>
+          <a:fillRef idx="3">
+            <a:schemeClr val="accent1"/>
+          </a:fillRef>
+          <a:effectRef idx="2">
+            <a:schemeClr val="accent1"/>
+          </a:effectRef>
+          <a:fontRef idx="minor">
+            <a:schemeClr val="lt1"/>
+          </a:fontRef>
+        </p:style>
+        <p:txBody>
+          <a:bodyPr rtlCol="0" anchor="ctr"/>
+          <a:lstStyle/>
+          <a:p>
+            <a:pPr algn="ctr"/>
+          </a:p>
+        </p:txBody>
+      </p:sp>
+      <p:sp>
+        <p:nvSpPr>
+          <p:cNvPr id="8" name="TextBox 7"/>
+          <p:cNvSpPr txBox="1"/>
+          <p:nvPr/>
+        </p:nvSpPr>
+        <p:spPr>
+          <a:xfrm>
+            <a:off x="1280160" y="2194560"/>
+            <a:ext cx="4498848" cy="2194560"/>
+          </a:xfrm>
+          <a:prstGeom prst="rect">
+            <a:avLst/>
+          </a:prstGeom>
+          <a:noFill/>
+        </p:spPr>
+        <p:txBody>
+          <a:bodyPr wrap="square">
+            <a:spAutoFit/>
+          </a:bodyPr>
+          <a:lstStyle/>
+          <a:p>
+            <a:pPr>
               <a:spcAft>
-                <a:spcPts val="3600"/>
+                <a:spcPts val="600"/>
               </a:spcAft>
-              <a:defRPr sz="1350">
+              <a:defRPr sz="1100" b="1">
+                <a:solidFill>
+                  <a:srgbClr val="581C87"/>
+                </a:solidFill>
+                <a:latin typeface="Segoe UI"/>
+              </a:defRPr>
+            </a:pPr>
+            <a:r>
+              <a:t>🎯 PETA KOMPETENSI 9 MODUL BMP UT</a:t>
+            </a:r>
+          </a:p>
+          <a:p>
+            <a:pPr>
+              <a:spcAft>
+                <a:spcPts val="400"/>
+              </a:spcAft>
+              <a:defRPr sz="950">
+                <a:solidFill>
+                  <a:srgbClr val="1E1E1E"/>
+                </a:solidFill>
+                <a:latin typeface="Segoe UI"/>
+              </a:defRPr>
+            </a:pPr>
+            <a:r>
+              <a:t>■  Modul 1–2 (20%): Arsitektur Hybrid, WebView Engine, Web Standards &amp; Vue 3 Composition API.</a:t>
+            </a:r>
+          </a:p>
+          <a:p>
+            <a:pPr>
+              <a:spcAft>
+                <a:spcPts val="400"/>
+              </a:spcAft>
+              <a:defRPr sz="950">
+                <a:solidFill>
+                  <a:srgbClr val="1E1E1E"/>
+                </a:solidFill>
+                <a:latin typeface="Segoe UI"/>
+              </a:defRPr>
+            </a:pPr>
+            <a:r>
+              <a:t>■  Modul 3–5 (32%): TypeScript Static Typing, Ionic UI Grid, Formulir Sanitasi Regex &amp; Dark Mode.</a:t>
+            </a:r>
+          </a:p>
+          <a:p>
+            <a:pPr>
+              <a:spcAft>
+                <a:spcPts val="400"/>
+              </a:spcAft>
+              <a:defRPr sz="950">
+                <a:solidFill>
+                  <a:srgbClr val="1E1E1E"/>
+                </a:solidFill>
+                <a:latin typeface="Segoe UI"/>
+              </a:defRPr>
+            </a:pPr>
+            <a:r>
+              <a:t>■  Modul 6–8 (32%): Capacitor Bridge Protocol, Android Studio, REST API, Offline Storage &amp; Hardware.</a:t>
+            </a:r>
+          </a:p>
+          <a:p>
+            <a:pPr>
+              <a:spcAft>
+                <a:spcPts val="400"/>
+              </a:spcAft>
+              <a:defRPr sz="950">
+                <a:solidFill>
+                  <a:srgbClr val="1E1E1E"/>
+                </a:solidFill>
+                <a:latin typeface="Segoe UI"/>
+              </a:defRPr>
+            </a:pPr>
+            <a:r>
+              <a:t>■  Modul 9 (16%): Kompilasi APK Release, Keystore Digital Signing, Minifikasi R8 &amp; Solusi Crash.</a:t>
+            </a:r>
+          </a:p>
+        </p:txBody>
+      </p:sp>
+      <p:sp>
+        <p:nvSpPr>
+          <p:cNvPr id="9" name="Rectangle 8"/>
+          <p:cNvSpPr/>
+          <p:nvPr/>
+        </p:nvSpPr>
+        <p:spPr>
+          <a:xfrm>
+            <a:off x="6302959" y="2130552"/>
+            <a:ext cx="4864608" cy="2468880"/>
+          </a:xfrm>
+          <a:prstGeom prst="rect">
+            <a:avLst/>
+          </a:prstGeom>
+          <a:solidFill>
+            <a:srgbClr val="000000"/>
+          </a:solidFill>
+          <a:ln>
+            <a:noFill/>
+          </a:ln>
+        </p:spPr>
+        <p:style>
+          <a:lnRef idx="1">
+            <a:schemeClr val="accent1"/>
+          </a:lnRef>
+          <a:fillRef idx="3">
+            <a:schemeClr val="accent1"/>
+          </a:fillRef>
+          <a:effectRef idx="2">
+            <a:schemeClr val="accent1"/>
+          </a:effectRef>
+          <a:fontRef idx="minor">
+            <a:schemeClr val="lt1"/>
+          </a:fontRef>
+        </p:style>
+        <p:txBody>
+          <a:bodyPr rtlCol="0" anchor="ctr"/>
+          <a:lstStyle/>
+          <a:p>
+            <a:pPr algn="ctr"/>
+          </a:p>
+        </p:txBody>
+      </p:sp>
+      <p:sp>
+        <p:nvSpPr>
+          <p:cNvPr id="10" name="Rectangle 9"/>
+          <p:cNvSpPr/>
+          <p:nvPr/>
+        </p:nvSpPr>
+        <p:spPr>
+          <a:xfrm>
+            <a:off x="6229807" y="2057400"/>
+            <a:ext cx="4864608" cy="2468880"/>
+          </a:xfrm>
+          <a:prstGeom prst="rect">
+            <a:avLst/>
+          </a:prstGeom>
+          <a:solidFill>
+            <a:srgbClr val="FEF3C7"/>
+          </a:solidFill>
+          <a:ln w="31750">
+            <a:solidFill>
+              <a:srgbClr val="000000"/>
+            </a:solidFill>
+          </a:ln>
+        </p:spPr>
+        <p:style>
+          <a:lnRef idx="1">
+            <a:schemeClr val="accent1"/>
+          </a:lnRef>
+          <a:fillRef idx="3">
+            <a:schemeClr val="accent1"/>
+          </a:fillRef>
+          <a:effectRef idx="2">
+            <a:schemeClr val="accent1"/>
+          </a:effectRef>
+          <a:fontRef idx="minor">
+            <a:schemeClr val="lt1"/>
+          </a:fontRef>
+        </p:style>
+        <p:txBody>
+          <a:bodyPr rtlCol="0" anchor="ctr"/>
+          <a:lstStyle/>
+          <a:p>
+            <a:pPr algn="ctr"/>
+          </a:p>
+        </p:txBody>
+      </p:sp>
+      <p:sp>
+        <p:nvSpPr>
+          <p:cNvPr id="11" name="TextBox 10"/>
+          <p:cNvSpPr txBox="1"/>
+          <p:nvPr/>
+        </p:nvSpPr>
+        <p:spPr>
+          <a:xfrm>
+            <a:off x="6412687" y="2194560"/>
+            <a:ext cx="4498848" cy="2194560"/>
+          </a:xfrm>
+          <a:prstGeom prst="rect">
+            <a:avLst/>
+          </a:prstGeom>
+          <a:noFill/>
+        </p:spPr>
+        <p:txBody>
+          <a:bodyPr wrap="square">
+            <a:spAutoFit/>
+          </a:bodyPr>
+          <a:lstStyle/>
+          <a:p>
+            <a:pPr>
+              <a:spcAft>
+                <a:spcPts val="600"/>
+              </a:spcAft>
+              <a:defRPr sz="1100" b="1">
+                <a:solidFill>
+                  <a:srgbClr val="92400E"/>
+                </a:solidFill>
+                <a:latin typeface="Segoe UI"/>
+              </a:defRPr>
+            </a:pPr>
+            <a:r>
+              <a:t>📱 FOKUS SESI 08 &amp; PENUTUP SEMESTER</a:t>
+            </a:r>
+          </a:p>
+          <a:p>
+            <a:pPr>
+              <a:spcAft>
+                <a:spcPts val="400"/>
+              </a:spcAft>
+              <a:defRPr sz="950">
+                <a:solidFill>
+                  <a:srgbClr val="1E1E1E"/>
+                </a:solidFill>
+                <a:latin typeface="Segoe UI"/>
+              </a:defRPr>
+            </a:pPr>
+            <a:r>
+              <a:t>■  Pembuatan Sertifikat Kriptografi: Keytool RSA-2048 &amp; Konfigurasi signingConfigs build.gradle.</a:t>
+            </a:r>
+          </a:p>
+          <a:p>
+            <a:pPr>
+              <a:spcAft>
+                <a:spcPts val="400"/>
+              </a:spcAft>
+              <a:defRPr sz="950">
+                <a:solidFill>
+                  <a:srgbClr val="1E1E1E"/>
+                </a:solidFill>
+                <a:latin typeface="Segoe UI"/>
+              </a:defRPr>
+            </a:pPr>
+            <a:r>
+              <a:t>■  Kompilasi Biner Mandiri: ./gradlew assembleRelease menghasilkan berkas .apk siap sideloading.</a:t>
+            </a:r>
+          </a:p>
+          <a:p>
+            <a:pPr>
+              <a:spcAft>
+                <a:spcPts val="400"/>
+              </a:spcAft>
+              <a:defRPr sz="950">
+                <a:solidFill>
+                  <a:srgbClr val="1E1E1E"/>
+                </a:solidFill>
+                <a:latin typeface="Segoe UI"/>
+              </a:defRPr>
+            </a:pPr>
+            <a:r>
+              <a:t>■  Optimasi &amp; Audit Keamanan: R8 Code Shrinking, WebP Asset Compression, dan Enforce HTTPS.</a:t>
+            </a:r>
+          </a:p>
+          <a:p>
+            <a:pPr>
+              <a:spcAft>
+                <a:spcPts val="400"/>
+              </a:spcAft>
+              <a:defRPr sz="950">
+                <a:solidFill>
+                  <a:srgbClr val="1E1E1E"/>
+                </a:solidFill>
+                <a:latin typeface="Segoe UI"/>
+              </a:defRPr>
+            </a:pPr>
+            <a:r>
+              <a:t>■  Master Solusi Lab Quest 08: Interactive APK Validator &amp; Simulasi Ujian 50 Soal UAS 90 Menit.</a:t>
+            </a:r>
+          </a:p>
+        </p:txBody>
+      </p:sp>
+      <p:sp>
+        <p:nvSpPr>
+          <p:cNvPr id="12" name="Rectangle 11"/>
+          <p:cNvSpPr/>
+          <p:nvPr/>
+        </p:nvSpPr>
+        <p:spPr>
+          <a:xfrm>
+            <a:off x="1133856" y="4745736"/>
+            <a:ext cx="9997135" cy="621792"/>
+          </a:xfrm>
+          <a:prstGeom prst="rect">
+            <a:avLst/>
+          </a:prstGeom>
+          <a:solidFill>
+            <a:srgbClr val="000000"/>
+          </a:solidFill>
+          <a:ln>
+            <a:noFill/>
+          </a:ln>
+        </p:spPr>
+        <p:style>
+          <a:lnRef idx="1">
+            <a:schemeClr val="accent1"/>
+          </a:lnRef>
+          <a:fillRef idx="3">
+            <a:schemeClr val="accent1"/>
+          </a:fillRef>
+          <a:effectRef idx="2">
+            <a:schemeClr val="accent1"/>
+          </a:effectRef>
+          <a:fontRef idx="minor">
+            <a:schemeClr val="lt1"/>
+          </a:fontRef>
+        </p:style>
+        <p:txBody>
+          <a:bodyPr rtlCol="0" anchor="ctr"/>
+          <a:lstStyle/>
+          <a:p>
+            <a:pPr algn="ctr"/>
+          </a:p>
+        </p:txBody>
+      </p:sp>
+      <p:sp>
+        <p:nvSpPr>
+          <p:cNvPr id="13" name="Rectangle 12">
+            <a:hlinkClick r:id="rId2"/>
+          </p:cNvPr>
+          <p:cNvSpPr/>
+          <p:nvPr/>
+        </p:nvSpPr>
+        <p:spPr>
+          <a:xfrm>
+            <a:off x="1097280" y="4709160"/>
+            <a:ext cx="9997135" cy="621792"/>
+          </a:xfrm>
+          <a:prstGeom prst="rect">
+            <a:avLst/>
+          </a:prstGeom>
+          <a:solidFill>
+            <a:srgbClr val="FFE600"/>
+          </a:solidFill>
+          <a:ln w="25400">
+            <a:solidFill>
+              <a:srgbClr val="000000"/>
+            </a:solidFill>
+          </a:ln>
+        </p:spPr>
+        <p:style>
+          <a:lnRef idx="1">
+            <a:schemeClr val="accent1"/>
+          </a:lnRef>
+          <a:fillRef idx="3">
+            <a:schemeClr val="accent1"/>
+          </a:fillRef>
+          <a:effectRef idx="2">
+            <a:schemeClr val="accent1"/>
+          </a:effectRef>
+          <a:fontRef idx="minor">
+            <a:schemeClr val="lt1"/>
+          </a:fontRef>
+        </p:style>
+        <p:txBody>
+          <a:bodyPr rtlCol="0" anchor="ctr"/>
+          <a:lstStyle/>
+          <a:p>
+            <a:pPr algn="ctr"/>
+          </a:p>
+        </p:txBody>
+      </p:sp>
+      <p:sp>
+        <p:nvSpPr>
+          <p:cNvPr id="14" name="TextBox 13"/>
+          <p:cNvSpPr txBox="1"/>
+          <p:nvPr/>
+        </p:nvSpPr>
+        <p:spPr>
+          <a:xfrm>
+            <a:off x="1188720" y="4745736"/>
+            <a:ext cx="9814255" cy="548640"/>
+          </a:xfrm>
+          <a:prstGeom prst="rect">
+            <a:avLst/>
+          </a:prstGeom>
+          <a:noFill/>
+        </p:spPr>
+        <p:txBody>
+          <a:bodyPr wrap="square">
+            <a:spAutoFit/>
+          </a:bodyPr>
+          <a:lstStyle/>
+          <a:p>
+            <a:pPr>
+              <a:spcAft>
+                <a:spcPts val="200"/>
+              </a:spcAft>
+              <a:defRPr sz="1000" b="1">
+                <a:solidFill>
+                  <a:srgbClr val="000000"/>
+                </a:solidFill>
+                <a:latin typeface="Segoe UI"/>
+              </a:defRPr>
+            </a:pPr>
+            <a:r>
+              <a:t>▶ KLIK DI SINI UNTUK MEMBUKA BERKAS INTERAKTIF ORIENTASI SESI 08 (slide_01_orientasi_sesi_08_final.html)</a:t>
+            </a:r>
+          </a:p>
+          <a:p>
+            <a:pPr>
+              <a:defRPr sz="750">
                 <a:solidFill>
                   <a:srgbClr val="3C3C3C"/>
                 </a:solidFill>
-                <a:latin typeface="Segoe UI"/>
-              </a:defRPr>
-            </a:pPr>
-            <a:r>
-              <a:t>Dari Kode Web Hybrid Menjadi Berkas Biner Android Mandiri yang Siap Edar serta Pembedahan Tuntas 50 Soal Komprehensif Ujian Akhir Semester</a:t>
-            </a:r>
-          </a:p>
-          <a:p>
-            <a:pPr>
-              <a:defRPr sz="1150" b="1">
+                <a:latin typeface="Consolas"/>
+              </a:defRPr>
+            </a:pPr>
+            <a:r>
+              <a:t>Tautan Langsung Berkas Pembelajaran: https://github.com/antonprafanto/tuweb_mobile2025/blob/main/contoh_kode_program/sesi_08_build_apk_uas/slide_01_orientasi_sesi_08_final.html</a:t>
+            </a:r>
+          </a:p>
+        </p:txBody>
+      </p:sp>
+      <p:sp>
+        <p:nvSpPr>
+          <p:cNvPr id="15" name="TextBox 14"/>
+          <p:cNvSpPr txBox="1"/>
+          <p:nvPr/>
+        </p:nvSpPr>
+        <p:spPr>
+          <a:xfrm>
+            <a:off x="1097280" y="5440680"/>
+            <a:ext cx="9997135" cy="365760"/>
+          </a:xfrm>
+          <a:prstGeom prst="rect">
+            <a:avLst/>
+          </a:prstGeom>
+          <a:noFill/>
+        </p:spPr>
+        <p:txBody>
+          <a:bodyPr wrap="none">
+            <a:spAutoFit/>
+          </a:bodyPr>
+          <a:lstStyle/>
+          <a:p>
+            <a:pPr>
+              <a:defRPr sz="950" b="1">
                 <a:solidFill>
                   <a:srgbClr val="000000"/>
                 </a:solidFill>

</xml_diff>